<commit_message>
Refine slide 7 (2-1): card-based research landscape diagram
Replace bubble chart with structured card layout:
- 4 international papers (RAG, ReAct, Self-RAG, GraphRAG) with colored cards
- 4 domestic works (RAG Survey, CRAG, Alibaba/Baidu, RAGAS/ARES)
- Center gap box highlighting the research opportunity
- Bottom bar summarizing the shared limitation

https://claude.ai/code/session_01XRVKRX3UhWBakg3Nb4t6Ux
</commit_message>
<xml_diff>
--- a/rag_ppt_v2.pptx
+++ b/rag_ppt_v2.pptx
@@ -12275,54 +12275,6 @@
           </a:p>
         </p:txBody>
       </p:sp>
-      <p:pic>
-        <p:nvPicPr>
-          <p:cNvPr id="7" name="Picture 6" descr="slide4_图片_18_94bc48a2.jpg"/>
-          <p:cNvPicPr>
-            <a:picLocks noChangeAspect="1"/>
-          </p:cNvPicPr>
-          <p:nvPr/>
-        </p:nvPicPr>
-        <p:blipFill>
-          <a:blip r:embed="rId2"/>
-          <a:stretch>
-            <a:fillRect/>
-          </a:stretch>
-        </p:blipFill>
-        <p:spPr>
-          <a:xfrm>
-            <a:off x="173736" y="82296"/>
-            <a:ext cx="768096" cy="768096"/>
-          </a:xfrm>
-          <a:prstGeom prst="rect">
-            <a:avLst/>
-          </a:prstGeom>
-        </p:spPr>
-      </p:pic>
-      <p:pic>
-        <p:nvPicPr>
-          <p:cNvPr id="8" name="Picture 7" descr="d2_landscape.png"/>
-          <p:cNvPicPr>
-            <a:picLocks noChangeAspect="1"/>
-          </p:cNvPicPr>
-          <p:nvPr/>
-        </p:nvPicPr>
-        <p:blipFill>
-          <a:blip r:embed="rId3"/>
-          <a:stretch>
-            <a:fillRect/>
-          </a:stretch>
-        </p:blipFill>
-        <p:spPr>
-          <a:xfrm>
-            <a:off x="365760" y="960120"/>
-            <a:ext cx="11430000" cy="5394960"/>
-          </a:xfrm>
-          <a:prstGeom prst="rect">
-            <a:avLst/>
-          </a:prstGeom>
-        </p:spPr>
-      </p:pic>
       <p:sp>
         <p:nvSpPr>
           <p:cNvPr id="9" name="TextBox 8"/>
@@ -12358,6 +12310,30 @@
           </a:p>
         </p:txBody>
       </p:sp>
+      <p:pic>
+        <p:nvPicPr>
+          <p:cNvPr id="10" name="Picture 9" descr="d2_landscape_v2.png"/>
+          <p:cNvPicPr>
+            <a:picLocks noChangeAspect="1"/>
+          </p:cNvPicPr>
+          <p:nvPr/>
+        </p:nvPicPr>
+        <p:blipFill>
+          <a:blip r:embed="rId4"/>
+          <a:stretch>
+            <a:fillRect/>
+          </a:stretch>
+        </p:blipFill>
+        <p:spPr>
+          <a:xfrm>
+            <a:off x="365760" y="960120"/>
+            <a:ext cx="11430000" cy="5394960"/>
+          </a:xfrm>
+          <a:prstGeom prst="rect">
+            <a:avLst/>
+          </a:prstGeom>
+        </p:spPr>
+      </p:pic>
     </p:spTree>
   </p:cSld>
   <p:clrMapOvr>

</xml_diff>